<commit_message>
Refresh social media officer presentation
Update the generated PowerPoint deck and its inspection metadata.
</commit_message>
<xml_diff>
--- a/.build_social/.codex-finalizer/candidate.pptx
+++ b/.build_social/.codex-finalizer/candidate.pptx
@@ -2,44 +2,44 @@
 <file path=ppt/presentation.xml><?xml version="1.0" encoding="utf-8"?>
 <p:presentation xmlns:p="http://schemas.openxmlformats.org/presentationml/2006/main" embedTrueTypeFonts="1" saveSubsetFonts="0">
   <p:sldMasterIdLst>
-    <p:sldMasterId xmlns:r="http://schemas.openxmlformats.org/officeDocument/2006/relationships" id="2147483648" r:id="R329693526c5146a3"/>
+    <p:sldMasterId xmlns:r="http://schemas.openxmlformats.org/officeDocument/2006/relationships" id="2147483648" r:id="R147f296f15214774"/>
   </p:sldMasterIdLst>
   <p:notesMasterIdLst>
-    <p:notesMasterId xmlns:r="http://schemas.openxmlformats.org/officeDocument/2006/relationships" r:id="Rb0dcf20ebbe44fc6"/>
+    <p:notesMasterId xmlns:r="http://schemas.openxmlformats.org/officeDocument/2006/relationships" r:id="Rfcfabc49566e4649"/>
   </p:notesMasterIdLst>
   <p:sldIdLst>
-    <p:sldId xmlns:r="http://schemas.openxmlformats.org/officeDocument/2006/relationships" id="256" r:id="Rcc14b01699494522"/>
-    <p:sldId xmlns:r="http://schemas.openxmlformats.org/officeDocument/2006/relationships" id="257" r:id="R4a0ec11ee3474d27"/>
-    <p:sldId xmlns:r="http://schemas.openxmlformats.org/officeDocument/2006/relationships" id="258" r:id="Rb6cdb354801d4ab0"/>
-    <p:sldId xmlns:r="http://schemas.openxmlformats.org/officeDocument/2006/relationships" id="259" r:id="Rae8c2a6e03734043"/>
-    <p:sldId xmlns:r="http://schemas.openxmlformats.org/officeDocument/2006/relationships" id="260" r:id="R730c7a7e14124f42"/>
-    <p:sldId xmlns:r="http://schemas.openxmlformats.org/officeDocument/2006/relationships" id="261" r:id="R3880c4c325bc4960"/>
-    <p:sldId xmlns:r="http://schemas.openxmlformats.org/officeDocument/2006/relationships" id="262" r:id="Rd410a9dc05c14de7"/>
-    <p:sldId xmlns:r="http://schemas.openxmlformats.org/officeDocument/2006/relationships" id="263" r:id="Red933919960e4958"/>
-    <p:sldId xmlns:r="http://schemas.openxmlformats.org/officeDocument/2006/relationships" id="264" r:id="R956fa4ae21064ec2"/>
-    <p:sldId xmlns:r="http://schemas.openxmlformats.org/officeDocument/2006/relationships" id="265" r:id="R0ce2e240fcbf492a"/>
-    <p:sldId xmlns:r="http://schemas.openxmlformats.org/officeDocument/2006/relationships" id="266" r:id="Rce16b6ad74414527"/>
-    <p:sldId xmlns:r="http://schemas.openxmlformats.org/officeDocument/2006/relationships" id="267" r:id="R7474b9ae3b8848b9"/>
-    <p:sldId xmlns:r="http://schemas.openxmlformats.org/officeDocument/2006/relationships" id="268" r:id="R4a5bfb18776943ad"/>
-    <p:sldId xmlns:r="http://schemas.openxmlformats.org/officeDocument/2006/relationships" id="269" r:id="Rd0d3934647bd450a"/>
-    <p:sldId xmlns:r="http://schemas.openxmlformats.org/officeDocument/2006/relationships" id="270" r:id="R93c4d24eb9bb4483"/>
-    <p:sldId xmlns:r="http://schemas.openxmlformats.org/officeDocument/2006/relationships" id="271" r:id="R34399d9608674a2e"/>
-    <p:sldId xmlns:r="http://schemas.openxmlformats.org/officeDocument/2006/relationships" id="272" r:id="R57d2ff74a5864fdd"/>
-    <p:sldId xmlns:r="http://schemas.openxmlformats.org/officeDocument/2006/relationships" id="273" r:id="R26129c05738f4a00"/>
-    <p:sldId xmlns:r="http://schemas.openxmlformats.org/officeDocument/2006/relationships" id="274" r:id="Re7ef6130c6114328"/>
-    <p:sldId xmlns:r="http://schemas.openxmlformats.org/officeDocument/2006/relationships" id="275" r:id="R0351209b8f2a4fe8"/>
-    <p:sldId xmlns:r="http://schemas.openxmlformats.org/officeDocument/2006/relationships" id="276" r:id="R22ca348a8f084ced"/>
-    <p:sldId xmlns:r="http://schemas.openxmlformats.org/officeDocument/2006/relationships" id="277" r:id="R97613987a9694255"/>
+    <p:sldId xmlns:r="http://schemas.openxmlformats.org/officeDocument/2006/relationships" id="256" r:id="R3f4d0ed39e524a53"/>
+    <p:sldId xmlns:r="http://schemas.openxmlformats.org/officeDocument/2006/relationships" id="257" r:id="R6fe397cd5b75441a"/>
+    <p:sldId xmlns:r="http://schemas.openxmlformats.org/officeDocument/2006/relationships" id="258" r:id="R2cda8283caeb424a"/>
+    <p:sldId xmlns:r="http://schemas.openxmlformats.org/officeDocument/2006/relationships" id="259" r:id="Rc0d95e291d714b48"/>
+    <p:sldId xmlns:r="http://schemas.openxmlformats.org/officeDocument/2006/relationships" id="260" r:id="Rd723c90048d741bc"/>
+    <p:sldId xmlns:r="http://schemas.openxmlformats.org/officeDocument/2006/relationships" id="261" r:id="Rfb0a0149f7c544cc"/>
+    <p:sldId xmlns:r="http://schemas.openxmlformats.org/officeDocument/2006/relationships" id="262" r:id="R9c58f87c810c45f5"/>
+    <p:sldId xmlns:r="http://schemas.openxmlformats.org/officeDocument/2006/relationships" id="263" r:id="R6006332a71494e16"/>
+    <p:sldId xmlns:r="http://schemas.openxmlformats.org/officeDocument/2006/relationships" id="264" r:id="R9c38434ec042409d"/>
+    <p:sldId xmlns:r="http://schemas.openxmlformats.org/officeDocument/2006/relationships" id="265" r:id="R57e499dba36b41fc"/>
+    <p:sldId xmlns:r="http://schemas.openxmlformats.org/officeDocument/2006/relationships" id="266" r:id="R15ba4e68296240e4"/>
+    <p:sldId xmlns:r="http://schemas.openxmlformats.org/officeDocument/2006/relationships" id="267" r:id="Rbd91029286b8412a"/>
+    <p:sldId xmlns:r="http://schemas.openxmlformats.org/officeDocument/2006/relationships" id="268" r:id="R59a328d2b66b42a8"/>
+    <p:sldId xmlns:r="http://schemas.openxmlformats.org/officeDocument/2006/relationships" id="269" r:id="R2e4ec566a235467c"/>
+    <p:sldId xmlns:r="http://schemas.openxmlformats.org/officeDocument/2006/relationships" id="270" r:id="R489b044936a44996"/>
+    <p:sldId xmlns:r="http://schemas.openxmlformats.org/officeDocument/2006/relationships" id="271" r:id="R0b96d69cbeea4f18"/>
+    <p:sldId xmlns:r="http://schemas.openxmlformats.org/officeDocument/2006/relationships" id="272" r:id="R8ffa0354dc13436d"/>
+    <p:sldId xmlns:r="http://schemas.openxmlformats.org/officeDocument/2006/relationships" id="273" r:id="Rf1e9db2f36314040"/>
+    <p:sldId xmlns:r="http://schemas.openxmlformats.org/officeDocument/2006/relationships" id="274" r:id="R0fbc4e8d2ad944a8"/>
+    <p:sldId xmlns:r="http://schemas.openxmlformats.org/officeDocument/2006/relationships" id="275" r:id="R13e42dd5d8bb4790"/>
+    <p:sldId xmlns:r="http://schemas.openxmlformats.org/officeDocument/2006/relationships" id="276" r:id="Rd0829e4ffa9c49fa"/>
+    <p:sldId xmlns:r="http://schemas.openxmlformats.org/officeDocument/2006/relationships" id="277" r:id="R0375bf0ece144428"/>
   </p:sldIdLst>
   <p:sldSz cx="12192000" cy="6858000"/>
   <p:notesSz cx="6858000" cy="9144000"/>
   <p:embeddedFontLst>
     <p:embeddedFont>
       <p:font typeface="Inter"/>
-      <p:regular xmlns:r="http://schemas.openxmlformats.org/officeDocument/2006/relationships" r:id="Rab55d83ca8a44231"/>
-      <p:bold xmlns:r="http://schemas.openxmlformats.org/officeDocument/2006/relationships" r:id="R3f23c1ac0c4c420f"/>
-      <p:italic xmlns:r="http://schemas.openxmlformats.org/officeDocument/2006/relationships" r:id="R2ba7b0b790294436"/>
-      <p:boldItalic xmlns:r="http://schemas.openxmlformats.org/officeDocument/2006/relationships" r:id="Rb46499289dfa4d1a"/>
+      <p:regular xmlns:r="http://schemas.openxmlformats.org/officeDocument/2006/relationships" r:id="Rd54944d403924eab"/>
+      <p:bold xmlns:r="http://schemas.openxmlformats.org/officeDocument/2006/relationships" r:id="Rd5450b99d8474187"/>
+      <p:italic xmlns:r="http://schemas.openxmlformats.org/officeDocument/2006/relationships" r:id="R449943edb2fb404c"/>
+      <p:boldItalic xmlns:r="http://schemas.openxmlformats.org/officeDocument/2006/relationships" r:id="R001a5a37b2624c43"/>
     </p:embeddedFont>
   </p:embeddedFontLst>
   <p:defaultTextStyle>
@@ -3970,7 +3970,7 @@
   </p:cSld>
   <p:clrMap bg1="lt1" tx1="dk1" bg2="dk2" tx2="lt2" accent1="accent1" accent2="accent2" accent3="accent3" accent4="accent4" accent5="accent5" accent6="accent6" hlink="hlink" folHlink="folHlink"/>
   <p:sldLayoutIdLst>
-    <p:sldLayoutId xmlns:r="http://schemas.openxmlformats.org/officeDocument/2006/relationships" id="2147483649" r:id="R4151b7a5795e45aa"/>
+    <p:sldLayoutId xmlns:r="http://schemas.openxmlformats.org/officeDocument/2006/relationships" id="2147483649" r:id="R7cc76cb48f9549fd"/>
   </p:sldLayoutIdLst>
   <p:hf sldNum="0" hdr="0" ftr="0" dt="0"/>
   <p:txStyles>
@@ -4924,7 +4924,7 @@
           <p:cNvPr id="16" name="Google Shape;16;p3">
             <a:extLst xmlns:a="http://schemas.openxmlformats.org/drawingml/2006/main">
               <a:ext uri="{FF2B5EF4-FFF2-40B4-BE49-F238E27FC236}">
-                <a16:creationId xmlns:a16="http://schemas.microsoft.com/office/drawing/2014/main" id="{1F793150-71AD-4831-82A8-F443C7595397}"/>
+                <a16:creationId xmlns:a16="http://schemas.microsoft.com/office/drawing/2014/main" id="{CA145909-1B50-42D3-9867-EAEB16408917}"/>
               </a:ext>
             </a:extLst>
           </p:cNvPr>
@@ -5258,7 +5258,7 @@
           <p:cNvPr id="21" name="Google Shape;21;p3">
             <a:extLst xmlns:a="http://schemas.openxmlformats.org/drawingml/2006/main">
               <a:ext uri="{FF2B5EF4-FFF2-40B4-BE49-F238E27FC236}">
-                <a16:creationId xmlns:a16="http://schemas.microsoft.com/office/drawing/2014/main" id="{F15CB4BE-EEA4-4492-BF91-370CE98CF548}"/>
+                <a16:creationId xmlns:a16="http://schemas.microsoft.com/office/drawing/2014/main" id="{270B6A70-E86C-4D7D-894C-07EE41326990}"/>
               </a:ext>
             </a:extLst>
           </p:cNvPr>
@@ -5268,7 +5268,7 @@
           <p:nvPr/>
         </p:nvPicPr>
         <p:blipFill rotWithShape="1">
-          <a:blip xmlns:r="http://schemas.openxmlformats.org/officeDocument/2006/relationships" xmlns:a="http://schemas.openxmlformats.org/drawingml/2006/main" r:embed="R65bdc24811eb45dc">
+          <a:blip xmlns:r="http://schemas.openxmlformats.org/officeDocument/2006/relationships" xmlns:a="http://schemas.openxmlformats.org/drawingml/2006/main" r:embed="R84c2a8d4a9b24221">
             <a:alphaModFix/>
           </a:blip>
           <a:srcRect xmlns:a="http://schemas.openxmlformats.org/drawingml/2006/main" l="0" t="0" r="0" b="0"/>
@@ -5321,7 +5321,7 @@
           <p:cNvPr id="123" name="Google Shape;123;p12">
             <a:extLst xmlns:a="http://schemas.openxmlformats.org/drawingml/2006/main">
               <a:ext uri="{FF2B5EF4-FFF2-40B4-BE49-F238E27FC236}">
-                <a16:creationId xmlns:a16="http://schemas.microsoft.com/office/drawing/2014/main" id="{304B212B-310F-47E5-9E31-AE4841009A0D}"/>
+                <a16:creationId xmlns:a16="http://schemas.microsoft.com/office/drawing/2014/main" id="{1D3F5A10-27BF-467F-9AC1-CFE8F3F74BB8}"/>
               </a:ext>
             </a:extLst>
           </p:cNvPr>
@@ -5784,7 +5784,7 @@
           <p:cNvPr id="129" name="Google Shape;129;p12">
             <a:extLst xmlns:a="http://schemas.openxmlformats.org/drawingml/2006/main">
               <a:ext uri="{FF2B5EF4-FFF2-40B4-BE49-F238E27FC236}">
-                <a16:creationId xmlns:a16="http://schemas.microsoft.com/office/drawing/2014/main" id="{DDE903FF-8AAD-4E63-81D0-24CE34F1F49C}"/>
+                <a16:creationId xmlns:a16="http://schemas.microsoft.com/office/drawing/2014/main" id="{B670D714-2AD8-4A64-8F83-DC60EEC39E49}"/>
               </a:ext>
             </a:extLst>
           </p:cNvPr>
@@ -5794,7 +5794,7 @@
           <p:nvPr/>
         </p:nvPicPr>
         <p:blipFill rotWithShape="1">
-          <a:blip xmlns:r="http://schemas.openxmlformats.org/officeDocument/2006/relationships" xmlns:a="http://schemas.openxmlformats.org/drawingml/2006/main" r:embed="R7baa53a435c7463d">
+          <a:blip xmlns:r="http://schemas.openxmlformats.org/officeDocument/2006/relationships" xmlns:a="http://schemas.openxmlformats.org/drawingml/2006/main" r:embed="R86ec223dbb684d32">
             <a:alphaModFix/>
           </a:blip>
           <a:srcRect xmlns:a="http://schemas.openxmlformats.org/drawingml/2006/main" l="0" t="0" r="0" b="0"/>
@@ -5847,7 +5847,7 @@
           <p:cNvPr id="135" name="Google Shape;135;p13">
             <a:extLst xmlns:a="http://schemas.openxmlformats.org/drawingml/2006/main">
               <a:ext uri="{FF2B5EF4-FFF2-40B4-BE49-F238E27FC236}">
-                <a16:creationId xmlns:a16="http://schemas.microsoft.com/office/drawing/2014/main" id="{86974A8B-947D-45E7-ACAD-B472067097E1}"/>
+                <a16:creationId xmlns:a16="http://schemas.microsoft.com/office/drawing/2014/main" id="{0307A5BB-6ABD-4EE3-8641-D2CBA4F5B09A}"/>
               </a:ext>
             </a:extLst>
           </p:cNvPr>
@@ -6307,7 +6307,7 @@
           <p:cNvPr id="141" name="Google Shape;141;p13">
             <a:extLst xmlns:a="http://schemas.openxmlformats.org/drawingml/2006/main">
               <a:ext uri="{FF2B5EF4-FFF2-40B4-BE49-F238E27FC236}">
-                <a16:creationId xmlns:a16="http://schemas.microsoft.com/office/drawing/2014/main" id="{655B19F7-CF7C-414B-89A0-7AB79740FC41}"/>
+                <a16:creationId xmlns:a16="http://schemas.microsoft.com/office/drawing/2014/main" id="{C44BCB90-92A1-48FA-B862-FE2B23BEA4DA}"/>
               </a:ext>
             </a:extLst>
           </p:cNvPr>
@@ -6317,7 +6317,7 @@
           <p:nvPr/>
         </p:nvPicPr>
         <p:blipFill rotWithShape="1">
-          <a:blip xmlns:r="http://schemas.openxmlformats.org/officeDocument/2006/relationships" xmlns:a="http://schemas.openxmlformats.org/drawingml/2006/main" r:embed="R2d7db92080da4f4c">
+          <a:blip xmlns:r="http://schemas.openxmlformats.org/officeDocument/2006/relationships" xmlns:a="http://schemas.openxmlformats.org/drawingml/2006/main" r:embed="Reb2a6abac56a4f12">
             <a:alphaModFix/>
           </a:blip>
           <a:srcRect xmlns:a="http://schemas.openxmlformats.org/drawingml/2006/main" l="0" t="0" r="0" b="0"/>
@@ -6370,7 +6370,7 @@
           <p:cNvPr id="147" name="Google Shape;147;p14">
             <a:extLst xmlns:a="http://schemas.openxmlformats.org/drawingml/2006/main">
               <a:ext uri="{FF2B5EF4-FFF2-40B4-BE49-F238E27FC236}">
-                <a16:creationId xmlns:a16="http://schemas.microsoft.com/office/drawing/2014/main" id="{D2684D03-88F3-4084-9A77-DC67812C82E9}"/>
+                <a16:creationId xmlns:a16="http://schemas.microsoft.com/office/drawing/2014/main" id="{26375147-C60D-492D-8431-80D7D13780B5}"/>
               </a:ext>
             </a:extLst>
           </p:cNvPr>
@@ -6830,7 +6830,7 @@
           <p:cNvPr id="153" name="Google Shape;153;p14">
             <a:extLst xmlns:a="http://schemas.openxmlformats.org/drawingml/2006/main">
               <a:ext uri="{FF2B5EF4-FFF2-40B4-BE49-F238E27FC236}">
-                <a16:creationId xmlns:a16="http://schemas.microsoft.com/office/drawing/2014/main" id="{C02D9D41-4757-4622-9FD7-B01A8D6DCD30}"/>
+                <a16:creationId xmlns:a16="http://schemas.microsoft.com/office/drawing/2014/main" id="{5AE17A1F-FF4D-4D1A-8F19-3A03060A0C95}"/>
               </a:ext>
             </a:extLst>
           </p:cNvPr>
@@ -6840,7 +6840,7 @@
           <p:nvPr/>
         </p:nvPicPr>
         <p:blipFill rotWithShape="1">
-          <a:blip xmlns:r="http://schemas.openxmlformats.org/officeDocument/2006/relationships" xmlns:a="http://schemas.openxmlformats.org/drawingml/2006/main" r:embed="Rb7f82bd5f5404762">
+          <a:blip xmlns:r="http://schemas.openxmlformats.org/officeDocument/2006/relationships" xmlns:a="http://schemas.openxmlformats.org/drawingml/2006/main" r:embed="Rf24e76f862194ea5">
             <a:alphaModFix/>
           </a:blip>
           <a:srcRect xmlns:a="http://schemas.openxmlformats.org/drawingml/2006/main" l="0" t="0" r="0" b="0"/>
@@ -6864,7 +6864,7 @@
           <p:cNvPr id="154" name="Google Shape;154;p14">
             <a:extLst xmlns:a="http://schemas.openxmlformats.org/drawingml/2006/main">
               <a:ext uri="{FF2B5EF4-FFF2-40B4-BE49-F238E27FC236}">
-                <a16:creationId xmlns:a16="http://schemas.microsoft.com/office/drawing/2014/main" id="{F796425A-A344-40AB-B0DD-06F3DC4D5D63}"/>
+                <a16:creationId xmlns:a16="http://schemas.microsoft.com/office/drawing/2014/main" id="{1F0817BA-0D8D-451A-B404-E212C3529DF5}"/>
               </a:ext>
             </a:extLst>
           </p:cNvPr>
@@ -6874,7 +6874,7 @@
           <p:nvPr/>
         </p:nvPicPr>
         <p:blipFill rotWithShape="1">
-          <a:blip xmlns:r="http://schemas.openxmlformats.org/officeDocument/2006/relationships" xmlns:a="http://schemas.openxmlformats.org/drawingml/2006/main" r:embed="Re8f6fdc275254290">
+          <a:blip xmlns:r="http://schemas.openxmlformats.org/officeDocument/2006/relationships" xmlns:a="http://schemas.openxmlformats.org/drawingml/2006/main" r:embed="R01d4101ac7ef420b">
             <a:alphaModFix/>
           </a:blip>
           <a:srcRect xmlns:a="http://schemas.openxmlformats.org/drawingml/2006/main" l="0" t="0" r="0" b="0"/>
@@ -6896,7 +6896,7 @@
       <p:sp>
         <p:nvSpPr>
           <p:cNvPr id="155" name="Google Shape;155;p14">
-            <a:hlinkClick xmlns:r="http://schemas.openxmlformats.org/officeDocument/2006/relationships" xmlns:a="http://schemas.openxmlformats.org/drawingml/2006/main" r:id="R68dbcda25fc54a52"/>
+            <a:hlinkClick xmlns:r="http://schemas.openxmlformats.org/officeDocument/2006/relationships" xmlns:a="http://schemas.openxmlformats.org/drawingml/2006/main" r:id="R9f56bb3ffa4a409a"/>
             <a:extLst xmlns:a="http://schemas.openxmlformats.org/drawingml/2006/main">
               <a:ext uri="{FF2B5EF4-FFF2-40B4-BE49-F238E27FC236}">
                 <a16:creationId xmlns:a16="http://schemas.microsoft.com/office/drawing/2014/main" id="{E4359F24-21DB-4C12-BD47-4FB38B330F54}"/>
@@ -6986,7 +6986,7 @@
           <p:cNvPr id="161" name="Google Shape;161;p15">
             <a:extLst xmlns:a="http://schemas.openxmlformats.org/drawingml/2006/main">
               <a:ext uri="{FF2B5EF4-FFF2-40B4-BE49-F238E27FC236}">
-                <a16:creationId xmlns:a16="http://schemas.microsoft.com/office/drawing/2014/main" id="{F9FE5B9E-E869-42A3-A13E-82DC9F665198}"/>
+                <a16:creationId xmlns:a16="http://schemas.microsoft.com/office/drawing/2014/main" id="{481401DC-23B9-48D2-8842-2A0FD91C22F7}"/>
               </a:ext>
             </a:extLst>
           </p:cNvPr>
@@ -7446,7 +7446,7 @@
           <p:cNvPr id="167" name="Google Shape;167;p15">
             <a:extLst xmlns:a="http://schemas.openxmlformats.org/drawingml/2006/main">
               <a:ext uri="{FF2B5EF4-FFF2-40B4-BE49-F238E27FC236}">
-                <a16:creationId xmlns:a16="http://schemas.microsoft.com/office/drawing/2014/main" id="{37D0D4AF-7693-4B35-8952-47E05F704497}"/>
+                <a16:creationId xmlns:a16="http://schemas.microsoft.com/office/drawing/2014/main" id="{B59C54A7-5639-4E9F-A7AF-5CFF68CE780B}"/>
               </a:ext>
             </a:extLst>
           </p:cNvPr>
@@ -7456,7 +7456,7 @@
           <p:nvPr/>
         </p:nvPicPr>
         <p:blipFill rotWithShape="1">
-          <a:blip xmlns:r="http://schemas.openxmlformats.org/officeDocument/2006/relationships" xmlns:a="http://schemas.openxmlformats.org/drawingml/2006/main" r:embed="Rdee7b1e486334458">
+          <a:blip xmlns:r="http://schemas.openxmlformats.org/officeDocument/2006/relationships" xmlns:a="http://schemas.openxmlformats.org/drawingml/2006/main" r:embed="R1bf833f0202b4824">
             <a:alphaModFix/>
           </a:blip>
           <a:srcRect xmlns:a="http://schemas.openxmlformats.org/drawingml/2006/main" l="0" t="0" r="0" b="0"/>
@@ -7509,7 +7509,7 @@
           <p:cNvPr id="173" name="Google Shape;173;p16">
             <a:extLst xmlns:a="http://schemas.openxmlformats.org/drawingml/2006/main">
               <a:ext uri="{FF2B5EF4-FFF2-40B4-BE49-F238E27FC236}">
-                <a16:creationId xmlns:a16="http://schemas.microsoft.com/office/drawing/2014/main" id="{6BE78357-CFDC-4984-AB1F-983DBCD97EA3}"/>
+                <a16:creationId xmlns:a16="http://schemas.microsoft.com/office/drawing/2014/main" id="{062362D6-EC07-4512-8FBB-2A68EE4484FE}"/>
               </a:ext>
             </a:extLst>
           </p:cNvPr>
@@ -7969,7 +7969,7 @@
           <p:cNvPr id="179" name="Google Shape;179;p16">
             <a:extLst xmlns:a="http://schemas.openxmlformats.org/drawingml/2006/main">
               <a:ext uri="{FF2B5EF4-FFF2-40B4-BE49-F238E27FC236}">
-                <a16:creationId xmlns:a16="http://schemas.microsoft.com/office/drawing/2014/main" id="{C7073811-2FD2-4BEE-9C4E-D03D520324FB}"/>
+                <a16:creationId xmlns:a16="http://schemas.microsoft.com/office/drawing/2014/main" id="{8898F191-35FB-4349-8BE4-35E11CF1FBF9}"/>
               </a:ext>
             </a:extLst>
           </p:cNvPr>
@@ -7979,7 +7979,7 @@
           <p:nvPr/>
         </p:nvPicPr>
         <p:blipFill rotWithShape="1">
-          <a:blip xmlns:r="http://schemas.openxmlformats.org/officeDocument/2006/relationships" xmlns:a="http://schemas.openxmlformats.org/drawingml/2006/main" r:embed="R1b9f38441698494e">
+          <a:blip xmlns:r="http://schemas.openxmlformats.org/officeDocument/2006/relationships" xmlns:a="http://schemas.openxmlformats.org/drawingml/2006/main" r:embed="R6c42b93accd74d70">
             <a:alphaModFix/>
           </a:blip>
           <a:srcRect xmlns:a="http://schemas.openxmlformats.org/drawingml/2006/main" l="0" t="0" r="0" b="0"/>
@@ -8032,7 +8032,7 @@
           <p:cNvPr id="185" name="Google Shape;185;p17">
             <a:extLst xmlns:a="http://schemas.openxmlformats.org/drawingml/2006/main">
               <a:ext uri="{FF2B5EF4-FFF2-40B4-BE49-F238E27FC236}">
-                <a16:creationId xmlns:a16="http://schemas.microsoft.com/office/drawing/2014/main" id="{F4831981-A1AA-45F3-9CA9-1D57926BFD07}"/>
+                <a16:creationId xmlns:a16="http://schemas.microsoft.com/office/drawing/2014/main" id="{DEBA6B0A-D5D8-4ACA-A005-28AF2001215B}"/>
               </a:ext>
             </a:extLst>
           </p:cNvPr>
@@ -8492,7 +8492,7 @@
           <p:cNvPr id="191" name="Google Shape;191;p17">
             <a:extLst xmlns:a="http://schemas.openxmlformats.org/drawingml/2006/main">
               <a:ext uri="{FF2B5EF4-FFF2-40B4-BE49-F238E27FC236}">
-                <a16:creationId xmlns:a16="http://schemas.microsoft.com/office/drawing/2014/main" id="{0800AA80-6919-4552-AC0A-833CF8D9A475}"/>
+                <a16:creationId xmlns:a16="http://schemas.microsoft.com/office/drawing/2014/main" id="{8FA0C007-EEB9-4D44-B351-FD029828AF3E}"/>
               </a:ext>
             </a:extLst>
           </p:cNvPr>
@@ -8502,7 +8502,7 @@
           <p:nvPr/>
         </p:nvPicPr>
         <p:blipFill rotWithShape="1">
-          <a:blip xmlns:r="http://schemas.openxmlformats.org/officeDocument/2006/relationships" xmlns:a="http://schemas.openxmlformats.org/drawingml/2006/main" r:embed="R46c19851214f49a4">
+          <a:blip xmlns:r="http://schemas.openxmlformats.org/officeDocument/2006/relationships" xmlns:a="http://schemas.openxmlformats.org/drawingml/2006/main" r:embed="Rb422b1fd08104d7c">
             <a:alphaModFix/>
           </a:blip>
           <a:srcRect xmlns:a="http://schemas.openxmlformats.org/drawingml/2006/main" l="0" t="0" r="0" b="0"/>
@@ -8555,7 +8555,7 @@
           <p:cNvPr id="197" name="Google Shape;197;p18">
             <a:extLst xmlns:a="http://schemas.openxmlformats.org/drawingml/2006/main">
               <a:ext uri="{FF2B5EF4-FFF2-40B4-BE49-F238E27FC236}">
-                <a16:creationId xmlns:a16="http://schemas.microsoft.com/office/drawing/2014/main" id="{FED0DF81-B0A9-4EB0-AE40-1F511422BD6B}"/>
+                <a16:creationId xmlns:a16="http://schemas.microsoft.com/office/drawing/2014/main" id="{F6BA6B4E-43D3-4E54-8E08-D3C3A219A4BD}"/>
               </a:ext>
             </a:extLst>
           </p:cNvPr>
@@ -9015,7 +9015,7 @@
           <p:cNvPr id="203" name="Google Shape;203;p18">
             <a:extLst xmlns:a="http://schemas.openxmlformats.org/drawingml/2006/main">
               <a:ext uri="{FF2B5EF4-FFF2-40B4-BE49-F238E27FC236}">
-                <a16:creationId xmlns:a16="http://schemas.microsoft.com/office/drawing/2014/main" id="{5C6B278F-3CF3-44D9-B017-6941ED545AA5}"/>
+                <a16:creationId xmlns:a16="http://schemas.microsoft.com/office/drawing/2014/main" id="{1E464F80-EE04-48E4-A550-A3FA242EAEC8}"/>
               </a:ext>
             </a:extLst>
           </p:cNvPr>
@@ -9025,7 +9025,7 @@
           <p:nvPr/>
         </p:nvPicPr>
         <p:blipFill rotWithShape="1">
-          <a:blip xmlns:r="http://schemas.openxmlformats.org/officeDocument/2006/relationships" xmlns:a="http://schemas.openxmlformats.org/drawingml/2006/main" r:embed="Re6197eea37534a8a">
+          <a:blip xmlns:r="http://schemas.openxmlformats.org/officeDocument/2006/relationships" xmlns:a="http://schemas.openxmlformats.org/drawingml/2006/main" r:embed="R674ea8fcd5bb4245">
             <a:alphaModFix/>
           </a:blip>
           <a:srcRect xmlns:a="http://schemas.openxmlformats.org/drawingml/2006/main" l="0" t="0" r="0" b="0"/>
@@ -9078,7 +9078,7 @@
           <p:cNvPr id="209" name="Google Shape;209;p19">
             <a:extLst xmlns:a="http://schemas.openxmlformats.org/drawingml/2006/main">
               <a:ext uri="{FF2B5EF4-FFF2-40B4-BE49-F238E27FC236}">
-                <a16:creationId xmlns:a16="http://schemas.microsoft.com/office/drawing/2014/main" id="{404EB1DC-F31D-412E-A471-9E2DA8D0B24B}"/>
+                <a16:creationId xmlns:a16="http://schemas.microsoft.com/office/drawing/2014/main" id="{C7E0EE02-3B37-4E31-BD2F-8D500B760CAE}"/>
               </a:ext>
             </a:extLst>
           </p:cNvPr>
@@ -9538,7 +9538,7 @@
           <p:cNvPr id="215" name="Google Shape;215;p19">
             <a:extLst xmlns:a="http://schemas.openxmlformats.org/drawingml/2006/main">
               <a:ext uri="{FF2B5EF4-FFF2-40B4-BE49-F238E27FC236}">
-                <a16:creationId xmlns:a16="http://schemas.microsoft.com/office/drawing/2014/main" id="{0FCE512D-CE72-4FDE-88CA-DC227972D55C}"/>
+                <a16:creationId xmlns:a16="http://schemas.microsoft.com/office/drawing/2014/main" id="{D055CEFF-441A-4002-BA67-0075A4079184}"/>
               </a:ext>
             </a:extLst>
           </p:cNvPr>
@@ -9548,7 +9548,7 @@
           <p:nvPr/>
         </p:nvPicPr>
         <p:blipFill rotWithShape="1">
-          <a:blip xmlns:r="http://schemas.openxmlformats.org/officeDocument/2006/relationships" xmlns:a="http://schemas.openxmlformats.org/drawingml/2006/main" r:embed="R54b9f27c43dc4e61">
+          <a:blip xmlns:r="http://schemas.openxmlformats.org/officeDocument/2006/relationships" xmlns:a="http://schemas.openxmlformats.org/drawingml/2006/main" r:embed="Ra15d7803af9b4844">
             <a:alphaModFix/>
           </a:blip>
           <a:srcRect xmlns:a="http://schemas.openxmlformats.org/drawingml/2006/main" l="0" t="0" r="0" b="0"/>
@@ -9601,7 +9601,7 @@
           <p:cNvPr id="221" name="Google Shape;221;p20">
             <a:extLst xmlns:a="http://schemas.openxmlformats.org/drawingml/2006/main">
               <a:ext uri="{FF2B5EF4-FFF2-40B4-BE49-F238E27FC236}">
-                <a16:creationId xmlns:a16="http://schemas.microsoft.com/office/drawing/2014/main" id="{71A31A0A-BD09-4BB6-A33E-A5181D1C0EE8}"/>
+                <a16:creationId xmlns:a16="http://schemas.microsoft.com/office/drawing/2014/main" id="{3D1BF59F-29BE-4FD0-A6B3-6F6079B8D992}"/>
               </a:ext>
             </a:extLst>
           </p:cNvPr>
@@ -10061,7 +10061,7 @@
           <p:cNvPr id="227" name="Google Shape;227;p20">
             <a:extLst xmlns:a="http://schemas.openxmlformats.org/drawingml/2006/main">
               <a:ext uri="{FF2B5EF4-FFF2-40B4-BE49-F238E27FC236}">
-                <a16:creationId xmlns:a16="http://schemas.microsoft.com/office/drawing/2014/main" id="{59962AC5-87BE-48A2-9361-46B7CC1938F0}"/>
+                <a16:creationId xmlns:a16="http://schemas.microsoft.com/office/drawing/2014/main" id="{2DB6F206-B335-453E-AE68-D3C3C92491FE}"/>
               </a:ext>
             </a:extLst>
           </p:cNvPr>
@@ -10071,7 +10071,7 @@
           <p:nvPr/>
         </p:nvPicPr>
         <p:blipFill rotWithShape="1">
-          <a:blip xmlns:r="http://schemas.openxmlformats.org/officeDocument/2006/relationships" xmlns:a="http://schemas.openxmlformats.org/drawingml/2006/main" r:embed="Rd769f5e91f204289">
+          <a:blip xmlns:r="http://schemas.openxmlformats.org/officeDocument/2006/relationships" xmlns:a="http://schemas.openxmlformats.org/drawingml/2006/main" r:embed="Ra3c5d4fd5e9a413c">
             <a:alphaModFix/>
           </a:blip>
           <a:srcRect xmlns:a="http://schemas.openxmlformats.org/drawingml/2006/main" l="0" t="0" r="0" b="0"/>
@@ -10124,7 +10124,7 @@
           <p:cNvPr id="233" name="Google Shape;233;p21">
             <a:extLst xmlns:a="http://schemas.openxmlformats.org/drawingml/2006/main">
               <a:ext uri="{FF2B5EF4-FFF2-40B4-BE49-F238E27FC236}">
-                <a16:creationId xmlns:a16="http://schemas.microsoft.com/office/drawing/2014/main" id="{F447D726-150C-44D8-ACB1-FBCE8A108127}"/>
+                <a16:creationId xmlns:a16="http://schemas.microsoft.com/office/drawing/2014/main" id="{138C3508-6EFC-4CF0-BC0F-2D767E365163}"/>
               </a:ext>
             </a:extLst>
           </p:cNvPr>
@@ -10584,7 +10584,7 @@
           <p:cNvPr id="239" name="Google Shape;239;p21">
             <a:extLst xmlns:a="http://schemas.openxmlformats.org/drawingml/2006/main">
               <a:ext uri="{FF2B5EF4-FFF2-40B4-BE49-F238E27FC236}">
-                <a16:creationId xmlns:a16="http://schemas.microsoft.com/office/drawing/2014/main" id="{D3730626-2356-4B1F-B6BE-9CB3261C7C6B}"/>
+                <a16:creationId xmlns:a16="http://schemas.microsoft.com/office/drawing/2014/main" id="{03F7DC30-86B5-4293-AA3D-A5CE1B935998}"/>
               </a:ext>
             </a:extLst>
           </p:cNvPr>
@@ -10594,7 +10594,7 @@
           <p:nvPr/>
         </p:nvPicPr>
         <p:blipFill rotWithShape="1">
-          <a:blip xmlns:r="http://schemas.openxmlformats.org/officeDocument/2006/relationships" xmlns:a="http://schemas.openxmlformats.org/drawingml/2006/main" r:embed="R21b0355e89e04ba4">
+          <a:blip xmlns:r="http://schemas.openxmlformats.org/officeDocument/2006/relationships" xmlns:a="http://schemas.openxmlformats.org/drawingml/2006/main" r:embed="Rcf7fe6ecfd5d4370">
             <a:alphaModFix/>
           </a:blip>
           <a:srcRect xmlns:a="http://schemas.openxmlformats.org/drawingml/2006/main" l="0" t="0" r="0" b="0"/>
@@ -10647,7 +10647,7 @@
           <p:cNvPr id="27" name="Google Shape;27;p4">
             <a:extLst xmlns:a="http://schemas.openxmlformats.org/drawingml/2006/main">
               <a:ext uri="{FF2B5EF4-FFF2-40B4-BE49-F238E27FC236}">
-                <a16:creationId xmlns:a16="http://schemas.microsoft.com/office/drawing/2014/main" id="{4099959B-9875-4B63-B965-A917830C8BDC}"/>
+                <a16:creationId xmlns:a16="http://schemas.microsoft.com/office/drawing/2014/main" id="{C058A168-BD96-4952-8199-1596C5E02475}"/>
               </a:ext>
             </a:extLst>
           </p:cNvPr>
@@ -11077,7 +11077,7 @@
           <p:cNvPr id="33" name="Google Shape;33;p4">
             <a:extLst xmlns:a="http://schemas.openxmlformats.org/drawingml/2006/main">
               <a:ext uri="{FF2B5EF4-FFF2-40B4-BE49-F238E27FC236}">
-                <a16:creationId xmlns:a16="http://schemas.microsoft.com/office/drawing/2014/main" id="{DF3F2510-6EF6-4904-9C89-3A8705232B86}"/>
+                <a16:creationId xmlns:a16="http://schemas.microsoft.com/office/drawing/2014/main" id="{A5C257F3-74A4-41FB-8E21-6E262C5F5822}"/>
               </a:ext>
             </a:extLst>
           </p:cNvPr>
@@ -11087,7 +11087,7 @@
           <p:nvPr/>
         </p:nvPicPr>
         <p:blipFill rotWithShape="1">
-          <a:blip xmlns:r="http://schemas.openxmlformats.org/officeDocument/2006/relationships" xmlns:a="http://schemas.openxmlformats.org/drawingml/2006/main" r:embed="Ra68d8755be6d4257">
+          <a:blip xmlns:r="http://schemas.openxmlformats.org/officeDocument/2006/relationships" xmlns:a="http://schemas.openxmlformats.org/drawingml/2006/main" r:embed="R135764f1fe774185">
             <a:alphaModFix/>
           </a:blip>
           <a:srcRect xmlns:a="http://schemas.openxmlformats.org/drawingml/2006/main" l="0" t="0" r="0" b="0"/>
@@ -11140,7 +11140,7 @@
           <p:cNvPr id="245" name="Google Shape;245;p22">
             <a:extLst xmlns:a="http://schemas.openxmlformats.org/drawingml/2006/main">
               <a:ext uri="{FF2B5EF4-FFF2-40B4-BE49-F238E27FC236}">
-                <a16:creationId xmlns:a16="http://schemas.microsoft.com/office/drawing/2014/main" id="{F3F76A97-E1EC-45C7-9990-736F99DCD0FC}"/>
+                <a16:creationId xmlns:a16="http://schemas.microsoft.com/office/drawing/2014/main" id="{4311A954-BA4D-458E-A118-51DB5F37A9EE}"/>
               </a:ext>
             </a:extLst>
           </p:cNvPr>
@@ -11600,7 +11600,7 @@
           <p:cNvPr id="251" name="Google Shape;251;p22">
             <a:extLst xmlns:a="http://schemas.openxmlformats.org/drawingml/2006/main">
               <a:ext uri="{FF2B5EF4-FFF2-40B4-BE49-F238E27FC236}">
-                <a16:creationId xmlns:a16="http://schemas.microsoft.com/office/drawing/2014/main" id="{FA2ED48A-13DA-446A-A4EA-52676E8F6C6B}"/>
+                <a16:creationId xmlns:a16="http://schemas.microsoft.com/office/drawing/2014/main" id="{4397A50C-A071-4EC1-A1E2-E1E5AC9F2152}"/>
               </a:ext>
             </a:extLst>
           </p:cNvPr>
@@ -11610,7 +11610,7 @@
           <p:nvPr/>
         </p:nvPicPr>
         <p:blipFill rotWithShape="1">
-          <a:blip xmlns:r="http://schemas.openxmlformats.org/officeDocument/2006/relationships" xmlns:a="http://schemas.openxmlformats.org/drawingml/2006/main" r:embed="R81c786e637274d71">
+          <a:blip xmlns:r="http://schemas.openxmlformats.org/officeDocument/2006/relationships" xmlns:a="http://schemas.openxmlformats.org/drawingml/2006/main" r:embed="R872f176af8744092">
             <a:alphaModFix/>
           </a:blip>
           <a:srcRect xmlns:a="http://schemas.openxmlformats.org/drawingml/2006/main" l="0" t="0" r="0" b="0"/>
@@ -11663,7 +11663,7 @@
           <p:cNvPr id="257" name="Google Shape;257;p23">
             <a:extLst xmlns:a="http://schemas.openxmlformats.org/drawingml/2006/main">
               <a:ext uri="{FF2B5EF4-FFF2-40B4-BE49-F238E27FC236}">
-                <a16:creationId xmlns:a16="http://schemas.microsoft.com/office/drawing/2014/main" id="{D78D7E35-E1D5-436C-837B-ACF7ACFB2EAC}"/>
+                <a16:creationId xmlns:a16="http://schemas.microsoft.com/office/drawing/2014/main" id="{B3968A5F-93E5-4AA9-93F6-79133642ACE9}"/>
               </a:ext>
             </a:extLst>
           </p:cNvPr>
@@ -12063,7 +12063,7 @@
           <p:cNvPr id="263" name="Google Shape;263;p23">
             <a:extLst xmlns:a="http://schemas.openxmlformats.org/drawingml/2006/main">
               <a:ext uri="{FF2B5EF4-FFF2-40B4-BE49-F238E27FC236}">
-                <a16:creationId xmlns:a16="http://schemas.microsoft.com/office/drawing/2014/main" id="{5800407A-0FAE-49D6-9374-ED69AD3E9F67}"/>
+                <a16:creationId xmlns:a16="http://schemas.microsoft.com/office/drawing/2014/main" id="{854CD808-4B85-417A-8722-F7CAC8894661}"/>
               </a:ext>
             </a:extLst>
           </p:cNvPr>
@@ -12073,7 +12073,7 @@
           <p:nvPr/>
         </p:nvPicPr>
         <p:blipFill rotWithShape="1">
-          <a:blip xmlns:r="http://schemas.openxmlformats.org/officeDocument/2006/relationships" xmlns:a="http://schemas.openxmlformats.org/drawingml/2006/main" r:embed="R115b8456da434f2d">
+          <a:blip xmlns:r="http://schemas.openxmlformats.org/officeDocument/2006/relationships" xmlns:a="http://schemas.openxmlformats.org/drawingml/2006/main" r:embed="R42804e984cc54885">
             <a:alphaModFix/>
           </a:blip>
           <a:srcRect xmlns:a="http://schemas.openxmlformats.org/drawingml/2006/main" l="0" t="0" r="0" b="0"/>
@@ -12126,7 +12126,7 @@
           <p:cNvPr id="269" name="Google Shape;269;p24">
             <a:extLst xmlns:a="http://schemas.openxmlformats.org/drawingml/2006/main">
               <a:ext uri="{FF2B5EF4-FFF2-40B4-BE49-F238E27FC236}">
-                <a16:creationId xmlns:a16="http://schemas.microsoft.com/office/drawing/2014/main" id="{A88FFD42-18FC-475E-8454-D99D197D3AAD}"/>
+                <a16:creationId xmlns:a16="http://schemas.microsoft.com/office/drawing/2014/main" id="{B75DB647-86EE-4F5D-9F8E-51EE1682A73C}"/>
               </a:ext>
             </a:extLst>
           </p:cNvPr>
@@ -12517,7 +12517,7 @@
           <p:cNvPr id="275" name="Google Shape;275;p24">
             <a:extLst xmlns:a="http://schemas.openxmlformats.org/drawingml/2006/main">
               <a:ext uri="{FF2B5EF4-FFF2-40B4-BE49-F238E27FC236}">
-                <a16:creationId xmlns:a16="http://schemas.microsoft.com/office/drawing/2014/main" id="{562EFD13-8C76-4054-BCCC-9F2A5DE1705D}"/>
+                <a16:creationId xmlns:a16="http://schemas.microsoft.com/office/drawing/2014/main" id="{C99E1E35-BF27-4B4F-A819-E5808290B645}"/>
               </a:ext>
             </a:extLst>
           </p:cNvPr>
@@ -12527,7 +12527,7 @@
           <p:nvPr/>
         </p:nvPicPr>
         <p:blipFill rotWithShape="1">
-          <a:blip xmlns:r="http://schemas.openxmlformats.org/officeDocument/2006/relationships" xmlns:a="http://schemas.openxmlformats.org/drawingml/2006/main" r:embed="R61fa951458244199">
+          <a:blip xmlns:r="http://schemas.openxmlformats.org/officeDocument/2006/relationships" xmlns:a="http://schemas.openxmlformats.org/drawingml/2006/main" r:embed="Rbfa37990cecb4b2c">
             <a:alphaModFix/>
           </a:blip>
           <a:srcRect xmlns:a="http://schemas.openxmlformats.org/drawingml/2006/main" l="0" t="0" r="0" b="0"/>
@@ -12580,7 +12580,7 @@
           <p:cNvPr id="39" name="Google Shape;39;p5">
             <a:extLst xmlns:a="http://schemas.openxmlformats.org/drawingml/2006/main">
               <a:ext uri="{FF2B5EF4-FFF2-40B4-BE49-F238E27FC236}">
-                <a16:creationId xmlns:a16="http://schemas.microsoft.com/office/drawing/2014/main" id="{2B9F6753-BF2A-4C73-8173-ECD1596112AB}"/>
+                <a16:creationId xmlns:a16="http://schemas.microsoft.com/office/drawing/2014/main" id="{203B94B3-8861-4FA8-98E0-96225FA4E47E}"/>
               </a:ext>
             </a:extLst>
           </p:cNvPr>
@@ -13010,7 +13010,7 @@
           <p:cNvPr id="45" name="Google Shape;45;p5">
             <a:extLst xmlns:a="http://schemas.openxmlformats.org/drawingml/2006/main">
               <a:ext uri="{FF2B5EF4-FFF2-40B4-BE49-F238E27FC236}">
-                <a16:creationId xmlns:a16="http://schemas.microsoft.com/office/drawing/2014/main" id="{1E5C9FFF-BBCD-4481-A54B-597451CBE6D8}"/>
+                <a16:creationId xmlns:a16="http://schemas.microsoft.com/office/drawing/2014/main" id="{317D47F8-7F06-456F-AC22-7DA2CF064C4B}"/>
               </a:ext>
             </a:extLst>
           </p:cNvPr>
@@ -13020,7 +13020,7 @@
           <p:nvPr/>
         </p:nvPicPr>
         <p:blipFill rotWithShape="1">
-          <a:blip xmlns:r="http://schemas.openxmlformats.org/officeDocument/2006/relationships" xmlns:a="http://schemas.openxmlformats.org/drawingml/2006/main" r:embed="R78b4efe256a84f31">
+          <a:blip xmlns:r="http://schemas.openxmlformats.org/officeDocument/2006/relationships" xmlns:a="http://schemas.openxmlformats.org/drawingml/2006/main" r:embed="R572cd7394da44dbc">
             <a:alphaModFix/>
           </a:blip>
           <a:srcRect xmlns:a="http://schemas.openxmlformats.org/drawingml/2006/main" l="0" t="0" r="0" b="0"/>
@@ -13073,7 +13073,7 @@
           <p:cNvPr id="51" name="Google Shape;51;p6">
             <a:extLst xmlns:a="http://schemas.openxmlformats.org/drawingml/2006/main">
               <a:ext uri="{FF2B5EF4-FFF2-40B4-BE49-F238E27FC236}">
-                <a16:creationId xmlns:a16="http://schemas.microsoft.com/office/drawing/2014/main" id="{8AA2F797-2152-4BA3-B068-A263EA2D680B}"/>
+                <a16:creationId xmlns:a16="http://schemas.microsoft.com/office/drawing/2014/main" id="{35516403-67B8-4270-AA4B-CDC1DC1B8549}"/>
               </a:ext>
             </a:extLst>
           </p:cNvPr>
@@ -13503,7 +13503,7 @@
           <p:cNvPr id="57" name="Google Shape;57;p6">
             <a:extLst xmlns:a="http://schemas.openxmlformats.org/drawingml/2006/main">
               <a:ext uri="{FF2B5EF4-FFF2-40B4-BE49-F238E27FC236}">
-                <a16:creationId xmlns:a16="http://schemas.microsoft.com/office/drawing/2014/main" id="{36903987-C067-417C-BEA4-E7F3BCF33FAE}"/>
+                <a16:creationId xmlns:a16="http://schemas.microsoft.com/office/drawing/2014/main" id="{25979DA4-2485-48D1-8D0B-6AD7D06CE0D1}"/>
               </a:ext>
             </a:extLst>
           </p:cNvPr>
@@ -13513,7 +13513,7 @@
           <p:nvPr/>
         </p:nvPicPr>
         <p:blipFill rotWithShape="1">
-          <a:blip xmlns:r="http://schemas.openxmlformats.org/officeDocument/2006/relationships" xmlns:a="http://schemas.openxmlformats.org/drawingml/2006/main" r:embed="R4d05f9ab4bc745bf">
+          <a:blip xmlns:r="http://schemas.openxmlformats.org/officeDocument/2006/relationships" xmlns:a="http://schemas.openxmlformats.org/drawingml/2006/main" r:embed="R62686fa29ead45c3">
             <a:alphaModFix/>
           </a:blip>
           <a:srcRect xmlns:a="http://schemas.openxmlformats.org/drawingml/2006/main" l="0" t="0" r="0" b="0"/>
@@ -13566,7 +13566,7 @@
           <p:cNvPr id="63" name="Google Shape;63;p7">
             <a:extLst xmlns:a="http://schemas.openxmlformats.org/drawingml/2006/main">
               <a:ext uri="{FF2B5EF4-FFF2-40B4-BE49-F238E27FC236}">
-                <a16:creationId xmlns:a16="http://schemas.microsoft.com/office/drawing/2014/main" id="{D55A2365-029A-4F7A-BE74-F0A048CAB48C}"/>
+                <a16:creationId xmlns:a16="http://schemas.microsoft.com/office/drawing/2014/main" id="{AEBD891A-7576-4414-ACEB-15D93AC360BE}"/>
               </a:ext>
             </a:extLst>
           </p:cNvPr>
@@ -13996,7 +13996,7 @@
           <p:cNvPr id="69" name="Google Shape;69;p7">
             <a:extLst xmlns:a="http://schemas.openxmlformats.org/drawingml/2006/main">
               <a:ext uri="{FF2B5EF4-FFF2-40B4-BE49-F238E27FC236}">
-                <a16:creationId xmlns:a16="http://schemas.microsoft.com/office/drawing/2014/main" id="{0A4DCD9F-C34F-4D51-B5C9-BE7C6D7D13DF}"/>
+                <a16:creationId xmlns:a16="http://schemas.microsoft.com/office/drawing/2014/main" id="{B429D33C-ACB1-4897-A60A-08826BD9CE15}"/>
               </a:ext>
             </a:extLst>
           </p:cNvPr>
@@ -14006,7 +14006,7 @@
           <p:nvPr/>
         </p:nvPicPr>
         <p:blipFill rotWithShape="1">
-          <a:blip xmlns:r="http://schemas.openxmlformats.org/officeDocument/2006/relationships" xmlns:a="http://schemas.openxmlformats.org/drawingml/2006/main" r:embed="R53275e24c97248de">
+          <a:blip xmlns:r="http://schemas.openxmlformats.org/officeDocument/2006/relationships" xmlns:a="http://schemas.openxmlformats.org/drawingml/2006/main" r:embed="Rd4666e1f44aa49b6">
             <a:alphaModFix/>
           </a:blip>
           <a:srcRect xmlns:a="http://schemas.openxmlformats.org/drawingml/2006/main" l="0" t="0" r="0" b="0"/>
@@ -14059,7 +14059,7 @@
           <p:cNvPr id="75" name="Google Shape;75;p8">
             <a:extLst xmlns:a="http://schemas.openxmlformats.org/drawingml/2006/main">
               <a:ext uri="{FF2B5EF4-FFF2-40B4-BE49-F238E27FC236}">
-                <a16:creationId xmlns:a16="http://schemas.microsoft.com/office/drawing/2014/main" id="{419884FA-6EE2-4066-B142-99A56186CFB4}"/>
+                <a16:creationId xmlns:a16="http://schemas.microsoft.com/office/drawing/2014/main" id="{9F50C992-A7A7-4632-9D3D-8F7BD6D97DA5}"/>
               </a:ext>
             </a:extLst>
           </p:cNvPr>
@@ -14489,7 +14489,7 @@
           <p:cNvPr id="81" name="Google Shape;81;p8">
             <a:extLst xmlns:a="http://schemas.openxmlformats.org/drawingml/2006/main">
               <a:ext uri="{FF2B5EF4-FFF2-40B4-BE49-F238E27FC236}">
-                <a16:creationId xmlns:a16="http://schemas.microsoft.com/office/drawing/2014/main" id="{5DCA77DE-852F-4DF3-8394-2299F1F70118}"/>
+                <a16:creationId xmlns:a16="http://schemas.microsoft.com/office/drawing/2014/main" id="{CEF9A2B4-0A35-46DB-8885-6EC641A15BD2}"/>
               </a:ext>
             </a:extLst>
           </p:cNvPr>
@@ -14499,7 +14499,7 @@
           <p:nvPr/>
         </p:nvPicPr>
         <p:blipFill rotWithShape="1">
-          <a:blip xmlns:r="http://schemas.openxmlformats.org/officeDocument/2006/relationships" xmlns:a="http://schemas.openxmlformats.org/drawingml/2006/main" r:embed="R2500620b33724f48">
+          <a:blip xmlns:r="http://schemas.openxmlformats.org/officeDocument/2006/relationships" xmlns:a="http://schemas.openxmlformats.org/drawingml/2006/main" r:embed="R47a11e6a841c4d43">
             <a:alphaModFix/>
           </a:blip>
           <a:srcRect xmlns:a="http://schemas.openxmlformats.org/drawingml/2006/main" l="0" t="0" r="0" b="0"/>
@@ -14552,7 +14552,7 @@
           <p:cNvPr id="87" name="Google Shape;87;p9">
             <a:extLst xmlns:a="http://schemas.openxmlformats.org/drawingml/2006/main">
               <a:ext uri="{FF2B5EF4-FFF2-40B4-BE49-F238E27FC236}">
-                <a16:creationId xmlns:a16="http://schemas.microsoft.com/office/drawing/2014/main" id="{5EDD43B7-426B-46BB-9A50-ABA96E3AC992}"/>
+                <a16:creationId xmlns:a16="http://schemas.microsoft.com/office/drawing/2014/main" id="{F2666837-002C-4B00-B82F-E259C9CAE86B}"/>
               </a:ext>
             </a:extLst>
           </p:cNvPr>
@@ -15012,7 +15012,7 @@
           <p:cNvPr id="93" name="Google Shape;93;p9">
             <a:extLst xmlns:a="http://schemas.openxmlformats.org/drawingml/2006/main">
               <a:ext uri="{FF2B5EF4-FFF2-40B4-BE49-F238E27FC236}">
-                <a16:creationId xmlns:a16="http://schemas.microsoft.com/office/drawing/2014/main" id="{D9D310EC-C583-4399-8CF6-2D5860FABB0D}"/>
+                <a16:creationId xmlns:a16="http://schemas.microsoft.com/office/drawing/2014/main" id="{703227E2-FD32-42B8-BA36-BF17B402B16B}"/>
               </a:ext>
             </a:extLst>
           </p:cNvPr>
@@ -15022,7 +15022,7 @@
           <p:nvPr/>
         </p:nvPicPr>
         <p:blipFill rotWithShape="1">
-          <a:blip xmlns:r="http://schemas.openxmlformats.org/officeDocument/2006/relationships" xmlns:a="http://schemas.openxmlformats.org/drawingml/2006/main" r:embed="R1619577db2c54ebb">
+          <a:blip xmlns:r="http://schemas.openxmlformats.org/officeDocument/2006/relationships" xmlns:a="http://schemas.openxmlformats.org/drawingml/2006/main" r:embed="R295b14e90aad43e6">
             <a:alphaModFix/>
           </a:blip>
           <a:srcRect xmlns:a="http://schemas.openxmlformats.org/drawingml/2006/main" l="0" t="0" r="0" b="0"/>
@@ -15075,7 +15075,7 @@
           <p:cNvPr id="99" name="Google Shape;99;p10">
             <a:extLst xmlns:a="http://schemas.openxmlformats.org/drawingml/2006/main">
               <a:ext uri="{FF2B5EF4-FFF2-40B4-BE49-F238E27FC236}">
-                <a16:creationId xmlns:a16="http://schemas.microsoft.com/office/drawing/2014/main" id="{7F5DCF14-D85F-4F57-8F9D-1209E003B3EB}"/>
+                <a16:creationId xmlns:a16="http://schemas.microsoft.com/office/drawing/2014/main" id="{00991F0D-6F4F-43A7-96E7-98CCD9DB8A7A}"/>
               </a:ext>
             </a:extLst>
           </p:cNvPr>
@@ -15535,7 +15535,7 @@
           <p:cNvPr id="105" name="Google Shape;105;p10">
             <a:extLst xmlns:a="http://schemas.openxmlformats.org/drawingml/2006/main">
               <a:ext uri="{FF2B5EF4-FFF2-40B4-BE49-F238E27FC236}">
-                <a16:creationId xmlns:a16="http://schemas.microsoft.com/office/drawing/2014/main" id="{F257DAB0-F84B-4D68-9F63-99168D9D3D38}"/>
+                <a16:creationId xmlns:a16="http://schemas.microsoft.com/office/drawing/2014/main" id="{0E8783B8-1F27-4C52-BADF-64B37CE2956A}"/>
               </a:ext>
             </a:extLst>
           </p:cNvPr>
@@ -15545,7 +15545,7 @@
           <p:nvPr/>
         </p:nvPicPr>
         <p:blipFill rotWithShape="1">
-          <a:blip xmlns:r="http://schemas.openxmlformats.org/officeDocument/2006/relationships" xmlns:a="http://schemas.openxmlformats.org/drawingml/2006/main" r:embed="R292a66b8571e4199">
+          <a:blip xmlns:r="http://schemas.openxmlformats.org/officeDocument/2006/relationships" xmlns:a="http://schemas.openxmlformats.org/drawingml/2006/main" r:embed="Rbc8f12cafe814eac">
             <a:alphaModFix/>
           </a:blip>
           <a:srcRect xmlns:a="http://schemas.openxmlformats.org/drawingml/2006/main" l="0" t="0" r="0" b="0"/>
@@ -15598,7 +15598,7 @@
           <p:cNvPr id="111" name="Google Shape;111;p11">
             <a:extLst xmlns:a="http://schemas.openxmlformats.org/drawingml/2006/main">
               <a:ext uri="{FF2B5EF4-FFF2-40B4-BE49-F238E27FC236}">
-                <a16:creationId xmlns:a16="http://schemas.microsoft.com/office/drawing/2014/main" id="{B54C7E5E-B77C-45EC-B02F-54EA5B5D6916}"/>
+                <a16:creationId xmlns:a16="http://schemas.microsoft.com/office/drawing/2014/main" id="{BADD3150-2D57-4217-8CD5-698736CC3C12}"/>
               </a:ext>
             </a:extLst>
           </p:cNvPr>
@@ -16058,7 +16058,7 @@
           <p:cNvPr id="117" name="Google Shape;117;p11">
             <a:extLst xmlns:a="http://schemas.openxmlformats.org/drawingml/2006/main">
               <a:ext uri="{FF2B5EF4-FFF2-40B4-BE49-F238E27FC236}">
-                <a16:creationId xmlns:a16="http://schemas.microsoft.com/office/drawing/2014/main" id="{C8C6F225-8FFB-4DD5-A1C8-AC5AC8CF45F9}"/>
+                <a16:creationId xmlns:a16="http://schemas.microsoft.com/office/drawing/2014/main" id="{59071E9C-026E-4026-B98B-07D2BA7E9DAC}"/>
               </a:ext>
             </a:extLst>
           </p:cNvPr>
@@ -16068,7 +16068,7 @@
           <p:nvPr/>
         </p:nvPicPr>
         <p:blipFill rotWithShape="1">
-          <a:blip xmlns:r="http://schemas.openxmlformats.org/officeDocument/2006/relationships" xmlns:a="http://schemas.openxmlformats.org/drawingml/2006/main" r:embed="Ra7f99cd3baa04932">
+          <a:blip xmlns:r="http://schemas.openxmlformats.org/officeDocument/2006/relationships" xmlns:a="http://schemas.openxmlformats.org/drawingml/2006/main" r:embed="R1b157d5943f341d3">
             <a:alphaModFix/>
           </a:blip>
           <a:srcRect xmlns:a="http://schemas.openxmlformats.org/drawingml/2006/main" l="0" t="0" r="0" b="0"/>

</xml_diff>